<commit_message>
Refresh PDF, PowerPoint, slide PNGs and README
Re-export all 15 slides from the current deck, rebuild the PDF and
PowerPoint with speaker notes, and update the README running order and
title image.

Co-authored-by: Copilot App <223556219+Copilot@users.noreply.github.com>
Copilot-Session: bd52ea7e-34c2-4802-afec-5eecb41ce65a
</commit_message>
<xml_diff>
--- a/AGNTCon-Europe-2026-Keynote.pptx
+++ b/AGNTCon-Europe-2026-Keynote.pptx
@@ -12,6 +12,14 @@
     <p:sldId id="260" r:id="rId12"/>
     <p:sldId id="261" r:id="rId13"/>
     <p:sldId id="262" r:id="rId14"/>
+    <p:sldId id="263" r:id="rId15"/>
+    <p:sldId id="264" r:id="rId16"/>
+    <p:sldId id="265" r:id="rId17"/>
+    <p:sldId id="266" r:id="rId18"/>
+    <p:sldId id="267" r:id="rId19"/>
+    <p:sldId id="268" r:id="rId20"/>
+    <p:sldId id="269" r:id="rId21"/>
+    <p:sldId id="270" r:id="rId22"/>
   </p:sldIdLst>
   <p:sldSz cx="12192000" cy="6858000" type="screen4x3"/>
   <p:notesSz cx="6858000" cy="9144000"/>
@@ -508,23 +516,427 @@
           <a:lstStyle/>
           <a:p>
             <a:r>
-              <a:t>AGNTCon Europe 2026, Amsterdam.</a:t>
-            </a:r>
-          </a:p>
-          <a:p>
-            <a:r>
-              <a:t>A New Way To Build Software: How GitHub Is Evolving For a Human, Agent Future</a:t>
-            </a:r>
-          </a:p>
-          <a:p>
-            <a:r>
-              <a:t>Marlene Mhangami — Senior Developer Advocate, Microsoft / GitHub.</a:t>
-            </a:r>
-          </a:p>
-          <a:p/>
-          <a:p>
-            <a:r>
-              <a:t>Artwork generated with the official GitHub Asset Generator MCP, general-social-banner-light-1. Layout direction inspired by the opening slides of marlene-playwright-talks-aieng. The reference deck was not modified.</a:t>
+              <a:t>AGNTCon + MCPCon Europe 2026, Amsterdam. A New Way To Build Software: how GitHub is evolving for a human, agent future. Marlene Mhangami, DevEx at GitHub. Ten minutes. The animated grid on the left is a real contribution graph.</a:t>
+            </a:r>
+          </a:p>
+        </p:txBody>
+      </p:sp>
+      <p:sp>
+        <p:nvSpPr>
+          <p:cNvPr id="4" name="Slide Number Placeholder 3"/>
+          <p:cNvSpPr>
+            <a:spLocks noGrp="1"/>
+          </p:cNvSpPr>
+          <p:nvPr>
+            <p:ph type="sldNum" idx="5" sz="quarter"/>
+          </p:nvPr>
+        </p:nvSpPr>
+        <p:spPr/>
+      </p:sp>
+    </p:spTree>
+  </p:cSld>
+  <p:clrMapOvr>
+    <a:masterClrMapping/>
+  </p:clrMapOvr>
+</p:notes>
+</file>
+
+<file path=ppt/notesSlides/notesSlide10.xml><?xml version="1.0" encoding="utf-8"?>
+<p:notes xmlns:a="http://schemas.openxmlformats.org/drawingml/2006/main" xmlns:p="http://schemas.openxmlformats.org/presentationml/2006/main" xmlns:r="http://schemas.openxmlformats.org/officeDocument/2006/relationships">
+  <p:cSld>
+    <p:spTree>
+      <p:nvGrpSpPr>
+        <p:cNvPr id="1" name=""/>
+        <p:cNvGrpSpPr/>
+        <p:nvPr/>
+      </p:nvGrpSpPr>
+      <p:grpSpPr>
+        <a:xfrm>
+          <a:off x="0" y="0"/>
+          <a:ext cx="0" cy="0"/>
+          <a:chOff x="0" y="0"/>
+          <a:chExt cx="0" cy="0"/>
+        </a:xfrm>
+      </p:grpSpPr>
+      <p:sp>
+        <p:nvSpPr>
+          <p:cNvPr id="2" name="Slide Image Placeholder 1"/>
+          <p:cNvSpPr>
+            <a:spLocks noGrp="1"/>
+          </p:cNvSpPr>
+          <p:nvPr>
+            <p:ph type="sldImg" idx="2"/>
+          </p:nvPr>
+        </p:nvSpPr>
+        <p:spPr/>
+      </p:sp>
+      <p:sp>
+        <p:nvSpPr>
+          <p:cNvPr id="3" name="Notes Placeholder 2"/>
+          <p:cNvSpPr>
+            <a:spLocks noGrp="1"/>
+          </p:cNvSpPr>
+          <p:nvPr>
+            <p:ph type="body" idx="3" sz="quarter"/>
+          </p:nvPr>
+        </p:nvSpPr>
+        <p:spPr/>
+        <p:txBody>
+          <a:bodyPr/>
+          <a:lstStyle/>
+          <a:p>
+            <a:r>
+              <a:t>Demo two, Issues. The issue now carries Artifacts: the human prompt, the agent's plan and thinking, the proposed fix, and before and after screenshots. Granular labels sit alongside. Everything the agent did is inspectable in the issue itself.</a:t>
+            </a:r>
+          </a:p>
+        </p:txBody>
+      </p:sp>
+      <p:sp>
+        <p:nvSpPr>
+          <p:cNvPr id="4" name="Slide Number Placeholder 3"/>
+          <p:cNvSpPr>
+            <a:spLocks noGrp="1"/>
+          </p:cNvSpPr>
+          <p:nvPr>
+            <p:ph type="sldNum" idx="5" sz="quarter"/>
+          </p:nvPr>
+        </p:nvSpPr>
+        <p:spPr/>
+      </p:sp>
+    </p:spTree>
+  </p:cSld>
+  <p:clrMapOvr>
+    <a:masterClrMapping/>
+  </p:clrMapOvr>
+</p:notes>
+</file>
+
+<file path=ppt/notesSlides/notesSlide11.xml><?xml version="1.0" encoding="utf-8"?>
+<p:notes xmlns:a="http://schemas.openxmlformats.org/drawingml/2006/main" xmlns:p="http://schemas.openxmlformats.org/presentationml/2006/main" xmlns:r="http://schemas.openxmlformats.org/officeDocument/2006/relationships">
+  <p:cSld>
+    <p:spTree>
+      <p:nvGrpSpPr>
+        <p:cNvPr id="1" name=""/>
+        <p:cNvGrpSpPr/>
+        <p:nvPr/>
+      </p:nvGrpSpPr>
+      <p:grpSpPr>
+        <a:xfrm>
+          <a:off x="0" y="0"/>
+          <a:ext cx="0" cy="0"/>
+          <a:chOff x="0" y="0"/>
+          <a:chExt cx="0" cy="0"/>
+        </a:xfrm>
+      </p:grpSpPr>
+      <p:sp>
+        <p:nvSpPr>
+          <p:cNvPr id="2" name="Slide Image Placeholder 1"/>
+          <p:cNvSpPr>
+            <a:spLocks noGrp="1"/>
+          </p:cNvSpPr>
+          <p:nvPr>
+            <p:ph type="sldImg" idx="2"/>
+          </p:nvPr>
+        </p:nvSpPr>
+        <p:spPr/>
+      </p:sp>
+      <p:sp>
+        <p:nvSpPr>
+          <p:cNvPr id="3" name="Notes Placeholder 2"/>
+          <p:cNvSpPr>
+            <a:spLocks noGrp="1"/>
+          </p:cNvSpPr>
+          <p:nvPr>
+            <p:ph type="body" idx="3" sz="quarter"/>
+          </p:nvPr>
+        </p:nvSpPr>
+        <p:spPr/>
+        <p:txBody>
+          <a:bodyPr/>
+          <a:lstStyle/>
+          <a:p>
+            <a:r>
+              <a:t>Demo three, Pull Requests. gh stack submit --auto creates the whole stack at once: three branches, three pull requests, linked as a stack on GitHub. Each reviewer sees only the layer they own.</a:t>
+            </a:r>
+          </a:p>
+        </p:txBody>
+      </p:sp>
+      <p:sp>
+        <p:nvSpPr>
+          <p:cNvPr id="4" name="Slide Number Placeholder 3"/>
+          <p:cNvSpPr>
+            <a:spLocks noGrp="1"/>
+          </p:cNvSpPr>
+          <p:nvPr>
+            <p:ph type="sldNum" idx="5" sz="quarter"/>
+          </p:nvPr>
+        </p:nvSpPr>
+        <p:spPr/>
+      </p:sp>
+    </p:spTree>
+  </p:cSld>
+  <p:clrMapOvr>
+    <a:masterClrMapping/>
+  </p:clrMapOvr>
+</p:notes>
+</file>
+
+<file path=ppt/notesSlides/notesSlide12.xml><?xml version="1.0" encoding="utf-8"?>
+<p:notes xmlns:a="http://schemas.openxmlformats.org/drawingml/2006/main" xmlns:p="http://schemas.openxmlformats.org/presentationml/2006/main" xmlns:r="http://schemas.openxmlformats.org/officeDocument/2006/relationships">
+  <p:cSld>
+    <p:spTree>
+      <p:nvGrpSpPr>
+        <p:cNvPr id="1" name=""/>
+        <p:cNvGrpSpPr/>
+        <p:nvPr/>
+      </p:nvGrpSpPr>
+      <p:grpSpPr>
+        <a:xfrm>
+          <a:off x="0" y="0"/>
+          <a:ext cx="0" cy="0"/>
+          <a:chOff x="0" y="0"/>
+          <a:chExt cx="0" cy="0"/>
+        </a:xfrm>
+      </p:grpSpPr>
+      <p:sp>
+        <p:nvSpPr>
+          <p:cNvPr id="2" name="Slide Image Placeholder 1"/>
+          <p:cNvSpPr>
+            <a:spLocks noGrp="1"/>
+          </p:cNvSpPr>
+          <p:nvPr>
+            <p:ph type="sldImg" idx="2"/>
+          </p:nvPr>
+        </p:nvSpPr>
+        <p:spPr/>
+      </p:sp>
+      <p:sp>
+        <p:nvSpPr>
+          <p:cNvPr id="3" name="Notes Placeholder 2"/>
+          <p:cNvSpPr>
+            <a:spLocks noGrp="1"/>
+          </p:cNvSpPr>
+          <p:nvPr>
+            <p:ph type="body" idx="3" sz="quarter"/>
+          </p:nvPr>
+        </p:nvSpPr>
+        <p:spPr/>
+        <p:txBody>
+          <a:bodyPr/>
+          <a:lstStyle/>
+          <a:p>
+            <a:r>
+              <a:t>Demo four, Pull Requests. The modern pull request experience: a Copilot-powered overview page with the new navigation, a merge readiness checklist, consolidated findings, and merging the whole stack from one control.</a:t>
+            </a:r>
+          </a:p>
+        </p:txBody>
+      </p:sp>
+      <p:sp>
+        <p:nvSpPr>
+          <p:cNvPr id="4" name="Slide Number Placeholder 3"/>
+          <p:cNvSpPr>
+            <a:spLocks noGrp="1"/>
+          </p:cNvSpPr>
+          <p:nvPr>
+            <p:ph type="sldNum" idx="5" sz="quarter"/>
+          </p:nvPr>
+        </p:nvSpPr>
+        <p:spPr/>
+      </p:sp>
+    </p:spTree>
+  </p:cSld>
+  <p:clrMapOvr>
+    <a:masterClrMapping/>
+  </p:clrMapOvr>
+</p:notes>
+</file>
+
+<file path=ppt/notesSlides/notesSlide13.xml><?xml version="1.0" encoding="utf-8"?>
+<p:notes xmlns:a="http://schemas.openxmlformats.org/drawingml/2006/main" xmlns:p="http://schemas.openxmlformats.org/presentationml/2006/main" xmlns:r="http://schemas.openxmlformats.org/officeDocument/2006/relationships">
+  <p:cSld>
+    <p:spTree>
+      <p:nvGrpSpPr>
+        <p:cNvPr id="1" name=""/>
+        <p:cNvGrpSpPr/>
+        <p:nvPr/>
+      </p:nvGrpSpPr>
+      <p:grpSpPr>
+        <a:xfrm>
+          <a:off x="0" y="0"/>
+          <a:ext cx="0" cy="0"/>
+          <a:chOff x="0" y="0"/>
+          <a:chExt cx="0" cy="0"/>
+        </a:xfrm>
+      </p:grpSpPr>
+      <p:sp>
+        <p:nvSpPr>
+          <p:cNvPr id="2" name="Slide Image Placeholder 1"/>
+          <p:cNvSpPr>
+            <a:spLocks noGrp="1"/>
+          </p:cNvSpPr>
+          <p:nvPr>
+            <p:ph type="sldImg" idx="2"/>
+          </p:nvPr>
+        </p:nvSpPr>
+        <p:spPr/>
+      </p:sp>
+      <p:sp>
+        <p:nvSpPr>
+          <p:cNvPr id="3" name="Notes Placeholder 2"/>
+          <p:cNvSpPr>
+            <a:spLocks noGrp="1"/>
+          </p:cNvSpPr>
+          <p:nvPr>
+            <p:ph type="body" idx="3" sz="quarter"/>
+          </p:nvPr>
+        </p:nvSpPr>
+        <p:spPr/>
+        <p:txBody>
+          <a:bodyPr/>
+          <a:lstStyle/>
+          <a:p>
+            <a:r>
+              <a:t>Maintainer controls, three that have shipped. Collaborators only, June 2026: restrict issue creation to write access and every public entry point closes with it. Agent automation controls, public preview July 2026: agents suggest instead of apply, with an approval queue, a confidence threshold you set, and a recorded rationale. Triage role exceptions, August 2026: trusted triagers keep working while the restriction holds. Gate the front door. Delegate safely. Keep agents on a leash inside the issue.</a:t>
+            </a:r>
+          </a:p>
+        </p:txBody>
+      </p:sp>
+      <p:sp>
+        <p:nvSpPr>
+          <p:cNvPr id="4" name="Slide Number Placeholder 3"/>
+          <p:cNvSpPr>
+            <a:spLocks noGrp="1"/>
+          </p:cNvSpPr>
+          <p:nvPr>
+            <p:ph type="sldNum" idx="5" sz="quarter"/>
+          </p:nvPr>
+        </p:nvSpPr>
+        <p:spPr/>
+      </p:sp>
+    </p:spTree>
+  </p:cSld>
+  <p:clrMapOvr>
+    <a:masterClrMapping/>
+  </p:clrMapOvr>
+</p:notes>
+</file>
+
+<file path=ppt/notesSlides/notesSlide14.xml><?xml version="1.0" encoding="utf-8"?>
+<p:notes xmlns:a="http://schemas.openxmlformats.org/drawingml/2006/main" xmlns:p="http://schemas.openxmlformats.org/presentationml/2006/main" xmlns:r="http://schemas.openxmlformats.org/officeDocument/2006/relationships">
+  <p:cSld>
+    <p:spTree>
+      <p:nvGrpSpPr>
+        <p:cNvPr id="1" name=""/>
+        <p:cNvGrpSpPr/>
+        <p:nvPr/>
+      </p:nvGrpSpPr>
+      <p:grpSpPr>
+        <a:xfrm>
+          <a:off x="0" y="0"/>
+          <a:ext cx="0" cy="0"/>
+          <a:chOff x="0" y="0"/>
+          <a:chExt cx="0" cy="0"/>
+        </a:xfrm>
+      </p:grpSpPr>
+      <p:sp>
+        <p:nvSpPr>
+          <p:cNvPr id="2" name="Slide Image Placeholder 1"/>
+          <p:cNvSpPr>
+            <a:spLocks noGrp="1"/>
+          </p:cNvSpPr>
+          <p:nvPr>
+            <p:ph type="sldImg" idx="2"/>
+          </p:nvPr>
+        </p:nvSpPr>
+        <p:spPr/>
+      </p:sp>
+      <p:sp>
+        <p:nvSpPr>
+          <p:cNvPr id="3" name="Notes Placeholder 2"/>
+          <p:cNvSpPr>
+            <a:spLocks noGrp="1"/>
+          </p:cNvSpPr>
+          <p:nvPr>
+            <p:ph type="body" idx="3" sz="quarter"/>
+          </p:nvPr>
+        </p:nvSpPr>
+        <p:spPr/>
+        <p:txBody>
+          <a:bodyPr/>
+          <a:lstStyle/>
+          <a:p>
+            <a:r>
+              <a:t>Close the loop. The same platform reaches the agents wherever the work happens: the GitHub MCP server, scheduled Agentic workflows, and Copilot in Slack and Teams.</a:t>
+            </a:r>
+          </a:p>
+        </p:txBody>
+      </p:sp>
+      <p:sp>
+        <p:nvSpPr>
+          <p:cNvPr id="4" name="Slide Number Placeholder 3"/>
+          <p:cNvSpPr>
+            <a:spLocks noGrp="1"/>
+          </p:cNvSpPr>
+          <p:nvPr>
+            <p:ph type="sldNum" idx="5" sz="quarter"/>
+          </p:nvPr>
+        </p:nvSpPr>
+        <p:spPr/>
+      </p:sp>
+    </p:spTree>
+  </p:cSld>
+  <p:clrMapOvr>
+    <a:masterClrMapping/>
+  </p:clrMapOvr>
+</p:notes>
+</file>
+
+<file path=ppt/notesSlides/notesSlide15.xml><?xml version="1.0" encoding="utf-8"?>
+<p:notes xmlns:a="http://schemas.openxmlformats.org/drawingml/2006/main" xmlns:p="http://schemas.openxmlformats.org/presentationml/2006/main" xmlns:r="http://schemas.openxmlformats.org/officeDocument/2006/relationships">
+  <p:cSld>
+    <p:spTree>
+      <p:nvGrpSpPr>
+        <p:cNvPr id="1" name=""/>
+        <p:cNvGrpSpPr/>
+        <p:nvPr/>
+      </p:nvGrpSpPr>
+      <p:grpSpPr>
+        <a:xfrm>
+          <a:off x="0" y="0"/>
+          <a:ext cx="0" cy="0"/>
+          <a:chOff x="0" y="0"/>
+          <a:chExt cx="0" cy="0"/>
+        </a:xfrm>
+      </p:grpSpPr>
+      <p:sp>
+        <p:nvSpPr>
+          <p:cNvPr id="2" name="Slide Image Placeholder 1"/>
+          <p:cNvSpPr>
+            <a:spLocks noGrp="1"/>
+          </p:cNvSpPr>
+          <p:nvPr>
+            <p:ph type="sldImg" idx="2"/>
+          </p:nvPr>
+        </p:nvSpPr>
+        <p:spPr/>
+      </p:sp>
+      <p:sp>
+        <p:nvSpPr>
+          <p:cNvPr id="3" name="Notes Placeholder 2"/>
+          <p:cNvSpPr>
+            <a:spLocks noGrp="1"/>
+          </p:cNvSpPr>
+          <p:nvPr>
+            <p:ph type="body" idx="3" sz="quarter"/>
+          </p:nvPr>
+        </p:nvSpPr>
+        <p:spPr/>
+        <p:txBody>
+          <a:bodyPr/>
+          <a:lstStyle/>
+          <a:p>
+            <a:r>
+              <a:t>Thank you. Slides at marlenezw.github.io/agntcon-mcpcon-europe-2026, code at github.com/marlenezw/agntcon-mcpcon-europe-2026. Find me at marlenezw on GitHub and X, marlenemhangami on LinkedIn.</a:t>
             </a:r>
           </a:p>
         </p:txBody>
@@ -594,78 +1006,7 @@
           <a:lstStyle/>
           <a:p>
             <a:r>
-              <a:t>Approved tracker wording:</a:t>
-            </a:r>
-          </a:p>
-          <a:p>
-            <a:r>
-              <a:t>“Commit volume is accelerating: we averaged 918M commits per week over the last 90 days, with August alone hitting 1.15B commits per week.”</a:t>
-            </a:r>
-          </a:p>
-          <a:p/>
-          <a:p>
-            <a:r>
-              <a:t>The user selected the published three-panel chart, then requested a light theme and a bottom caption. The curves, values, and axes are preserved. Only colors and exterior padding have changed. All three panels show MONTHLY measures: merged PRs, commits, and new repos. The 1.15B WEEKLY figure is displayed as a separate bottom caption, explicitly distinguished from the monthly graphs. No weekly-to-monthly conversion is implied.</a:t>
-            </a:r>
-          </a:p>
-          <a:p/>
-          <a:p>
-            <a:r>
-              <a:t>Public source for the original chart:</a:t>
-            </a:r>
-          </a:p>
-          <a:p>
-            <a:r>
-              <a:t>https://github.blog/news-insights/company-news/the-august-17-outage-and-the-work-ahead/</a:t>
-            </a:r>
-          </a:p>
-          <a:p>
-            <a:r>
-              <a:t>https://github.blog/wp-content/uploads/2026/08/blog-post-aug-17-outage-1.png</a:t>
-            </a:r>
-          </a:p>
-          <a:p/>
-          <a:p>
-            <a:r>
-              <a:t>Source: Business Insights. Tracker last updated September 2026; next review October 2026; POC Abby Rieflin.</a:t>
-            </a:r>
-          </a:p>
-          <a:p>
-            <a:r>
-              <a:t>https://github.com/github/public-relations/blob/master/Corp%20Comms%20External%20Reference%20Tracker.md</a:t>
-            </a:r>
-          </a:p>
-          <a:p>
-            <a:r>
-              <a:t>Approval provenance: external-reference update merged September 11, 2026:</a:t>
-            </a:r>
-          </a:p>
-          <a:p>
-            <a:r>
-              <a:t>https://github.com/github/public-relations/pull/1136</a:t>
-            </a:r>
-          </a:p>
-          <a:p>
-            <a:r>
-              <a:t>https://github-grid.enterprise.slack.com/archives/C0F7EKL80/p1789158083089459</a:t>
-            </a:r>
-          </a:p>
-          <a:p/>
-          <a:p>
-            <a:r>
-              <a:t>IMPORTANT: This is all GitHub commit activity, not a count of agent-authored commits. No approved agent-attributed commit count or percentage was found.</a:t>
-            </a:r>
-          </a:p>
-          <a:p/>
-          <a:p>
-            <a:r>
-              <a:t>Suggested transition: GitHub has to evolve both how work is produced and how people review, govern, and trust it.</a:t>
-            </a:r>
-          </a:p>
-          <a:p/>
-          <a:p>
-            <a:r>
-              <a:t>This light-theme line-chart slide precedes the PR bar-chart slide.</a:t>
+              <a:t>Open on volume. Source: GitHub Octoverse 2025. 43.2 million pull requests merged every month, up 23 percent year over year. 986 million commits pushed in 2025, up 25 percent. Nearly a billion commits, GitHub's most active year ever.</a:t>
             </a:r>
           </a:p>
         </p:txBody>
@@ -735,51 +1076,7 @@
           <a:lstStyle/>
           <a:p>
             <a:r>
-              <a:t>Slide title: Agent Driven Growth. Layout inspired by the 'Growth Is Accelerating' slide of marlene-playwright-talks-aieng, restyled to match the light-theme commits slide. The reference deck was not modified.</a:t>
-            </a:r>
-          </a:p>
-          <a:p/>
-          <a:p>
-            <a:r>
-              <a:t>Approved statistics:</a:t>
-            </a:r>
-          </a:p>
-          <a:p>
-            <a:r>
-              <a:t>• 17.8 million pull requests CREATED BY AGENTS in March 2026 alone (agent-generated PRs quadrupled in six months). Source: Platform Activity March 2026, Corp Comms External Reference Tracker; POC Julia Tenner.</a:t>
-            </a:r>
-          </a:p>
-          <a:p>
-            <a:r>
-              <a:t>• Monthly commits grew from 1.4 billion (April 2026) to 2.9 billion (August 2026). Source: GitHub Blog, 'The August 17 outage, and the work ahead':</a:t>
-            </a:r>
-          </a:p>
-          <a:p>
-            <a:r>
-              <a:t>https://github.blog/news-insights/company-news/the-august-17-outage-and-the-work-ahead/</a:t>
-            </a:r>
-          </a:p>
-          <a:p>
-            <a:r>
-              <a:t>• Contrast: GitHub recorded ~1 billion commits in ALL of 2024 (GitHub Octoverse; also cited on the 'Growth Is Accelerating' slide of the reference deck). So a single month in 2026 (2.9B) now exceeds the entire 2024 calendar year.</a:t>
-            </a:r>
-          </a:p>
-          <a:p/>
-          <a:p>
-            <a:r>
-              <a:t>https://github.com/github/public-relations/blob/master/Corp%20Comms%20External%20Reference%20Tracker.md</a:t>
-            </a:r>
-          </a:p>
-          <a:p/>
-          <a:p>
-            <a:r>
-              <a:t>ACCURACY: The left figure is agent-created pull requests, NOT commits, merged PRs, or Copilot-only contributions. The right figure is TOTAL platform commits, NOT an agent-attributed commit count (no approved agent-commit count exists). Both mini-charts are illustrative: the shapes convey the 4x and ~2x trajectories and the labeled endpoints are the approved values; intermediate points are stylized, not observed data.</a:t>
-            </a:r>
-          </a:p>
-          <a:p/>
-          <a:p>
-            <a:r>
-              <a:t>Suggested transition: More contributions do not automatically mean better software — review capacity, governance, and trust now matter even more.</a:t>
+              <a:t>Zoom out to the trend line, 2023 to August 2026. 130 million merged pull requests per month, 2.9 billion commits per month, 24 million new repositories per month. GitHub reached 1.158 billion commits in a single week in August 2026. Source: GitHub Blog, The August '26 usage and the work ahead.</a:t>
             </a:r>
           </a:p>
         </p:txBody>
@@ -849,19 +1146,7 @@
           <a:lstStyle/>
           <a:p>
             <a:r>
-              <a:t>Transition slide. Statement: 'AI has boosted productivity for some, and left others feeling overwhelmed.'</a:t>
-            </a:r>
-          </a:p>
-          <a:p/>
-          <a:p>
-            <a:r>
-              <a:t>Sets up the next slide, which contrasts two sets of REAL, public GitHub issues: developers asking for more agentic capability vs. maintainers asking for guardrails against low-effort AI contributions.</a:t>
-            </a:r>
-          </a:p>
-          <a:p/>
-          <a:p>
-            <a:r>
-              <a:t>Suggested delivery: pause here. The same wave of agent productivity that thrills some developers is straining others. Both are visible in the open, in public issue trackers.</a:t>
+              <a:t>It is not just people typing. Completed GitHub Actions runs hit 115.4 million, nearly 4 times since January. The August peak moved from roughly 15 million to 30 million earlier in 2026. Azure now serves roughly 56 percent of GitHub's platform load, up from 12 percent in May. That expanded footprint is what supports this growth.</a:t>
             </a:r>
           </a:p>
         </p:txBody>
@@ -931,107 +1216,7 @@
           <a:lstStyle/>
           <a:p>
             <a:r>
-              <a:t>Animated split-screen: real, PUBLIC GitHub issues drop into two zones —</a:t>
-            </a:r>
-          </a:p>
-          <a:p>
-            <a:r>
-              <a:t>'Leaning In' (developers asking for more agentic capability) and 'Overwhelmed' (maintainers asking for guardrails).</a:t>
-            </a:r>
-          </a:p>
-          <a:p/>
-          <a:p>
-            <a:r>
-              <a:t>In PowerPoint each card is a separate object with a native Fly-In-from-top entrance; they cascade in automatically shortly after the slide appears (and again on click if you advance the build). The exported PDF/preview shows the final resting state.</a:t>
-            </a:r>
-          </a:p>
-          <a:p/>
-          <a:p>
-            <a:r>
-              <a:t>Leaning In (public issues):</a:t>
-            </a:r>
-          </a:p>
-          <a:p>
-            <a:r>
-              <a:t>• cli/cli#11845 — gh agent-task create shouldn't require OAUTH tokens — 44</a:t>
-            </a:r>
-          </a:p>
-          <a:p>
-            <a:r>
-              <a:t>  https://github.com/cli/cli/issues/11845</a:t>
-            </a:r>
-          </a:p>
-          <a:p>
-            <a:r>
-              <a:t>• cli/cli#12960 — image/file attachments in gh issue create (title literally reads 'critical for agentic workflows') — DISPLAYED as 63.</a:t>
-            </a:r>
-          </a:p>
-          <a:p>
-            <a:r>
-              <a:t>  NOTE: this issue's own +1 count is 4. The 63 shown on the slide is the +1 count of the closely related umbrella request cli/cli#1895 (Upload and Embed Files to PRs/Issues/Comments); presenter chose to surface the stronger number with the agentic-titled issue. If asked, cite #1895 for the 63 figure.</a:t>
-            </a:r>
-          </a:p>
-          <a:p>
-            <a:r>
-              <a:t>  https://github.com/cli/cli/issues/12960  (related: https://github.com/cli/cli/issues/1895)</a:t>
-            </a:r>
-          </a:p>
-          <a:p>
-            <a:r>
-              <a:t>• github/spec-kit#269 — support multiple coding agents — 21</a:t>
-            </a:r>
-          </a:p>
-          <a:p>
-            <a:r>
-              <a:t>  https://github.com/github/spec-kit/issues/269</a:t>
-            </a:r>
-          </a:p>
-          <a:p/>
-          <a:p>
-            <a:r>
-              <a:t>Overwhelmed (public issues, +1 as of Sep 14, 2026):</a:t>
-            </a:r>
-          </a:p>
-          <a:p>
-            <a:r>
-              <a:t>• rust-lang/this-week-in-rust#6861 — suspicious AI-generated article / supply-chain concern — 60</a:t>
-            </a:r>
-          </a:p>
-          <a:p>
-            <a:r>
-              <a:t>  https://github.com/rust-lang/this-week-in-rust/issues/6861</a:t>
-            </a:r>
-          </a:p>
-          <a:p>
-            <a:r>
-              <a:t>• mastodon/mastodon#38072 — consider not allowing LLM and AI contributions — 40</a:t>
-            </a:r>
-          </a:p>
-          <a:p>
-            <a:r>
-              <a:t>  https://github.com/mastodon/mastodon/issues/38072</a:t>
-            </a:r>
-          </a:p>
-          <a:p>
-            <a:r>
-              <a:t>• rust-lang/leadership-council#273 — policy proposal: no low-effort contributions — 38</a:t>
-            </a:r>
-          </a:p>
-          <a:p>
-            <a:r>
-              <a:t>  https://github.com/rust-lang/leadership-council/issues/273</a:t>
-            </a:r>
-          </a:p>
-          <a:p/>
-          <a:p>
-            <a:r>
-              <a:t>All issues are in public repositories and are safe to show on screen. Card titles are lightly condensed from the originals; none introduce an em dash that the source title did not use.</a:t>
-            </a:r>
-          </a:p>
-          <a:p/>
-          <a:p>
-            <a:r>
-              <a:t>Suggested transition: this is exactly the gap GitHub is closing — better tools for the people leaning in, and real guardrails for the people keeping projects healthy.</a:t>
+              <a:t>Summarise the three data slides. More code. More automation. And much of that code is co-authored by AI agents: 17.8 million agent-created pull requests in March 2026 alone. Agent-created pull requests quadrupled in six months. Approved external statistic, do not round or re-date it.</a:t>
             </a:r>
           </a:p>
         </p:txBody>
@@ -1101,13 +1286,7 @@
           <a:lstStyle/>
           <a:p>
             <a:r>
-              <a:t>Section-divider slide. Large statement: 'The Modern GitHub Experience.'</a:t>
-            </a:r>
-          </a:p>
-          <a:p/>
-          <a:p>
-            <a:r>
-              <a:t>Pivot from the tension (previous two slides) into what GitHub is doing about it. Delivery: this is the turn — from the problem to GitHub's answer. The next slide breaks down what that experience covers for both audiences.</a:t>
+              <a:t>Transition. The numbers are settled. The question for the rest of the talk is what all this volume has done to the people doing the work.</a:t>
             </a:r>
           </a:p>
         </p:txBody>
@@ -1177,34 +1356,147 @@
           <a:lstStyle/>
           <a:p>
             <a:r>
-              <a:t>Slide title: The Modern GitHub Experience. Agenda slide — the three areas the rest of the talk covers: Issues, PRs, and Maintainer Controls. Grounded in Marlene's GitHub Universe platform planning work (contributor experience + open-source maintainer control).</a:t>
-            </a:r>
-          </a:p>
-          <a:p/>
-          <a:p>
-            <a:r>
-              <a:t>Talking points to expand each bullet live (keep specific internal release IDs off-screen):</a:t>
-            </a:r>
-          </a:p>
-          <a:p>
-            <a:r>
-              <a:t>• Issues — attach screenshots &amp; files (gh --attach / image &amp; file attachments); plans, before/after and reports as Artifacts.</a:t>
-            </a:r>
-          </a:p>
-          <a:p>
-            <a:r>
-              <a:t>• PRs — agents ship changes as stacked PRs (one reviewable PR per plan step); Findings and the Overview tab to review and merge with confidence.</a:t>
-            </a:r>
-          </a:p>
-          <a:p>
-            <a:r>
-              <a:t>• Maintainer Controls — restrict who can open issues &amp; PRs; queue limits (max open PRs &amp; issues + allowlists); commit-comment controls; triage-role exceptions to stay flexible.</a:t>
-            </a:r>
-          </a:p>
-          <a:p/>
-          <a:p>
-            <a:r>
-              <a:t>Suggested delivery: 'We're building for both people in that split-screen — the ones leaning in, and the ones keeping projects healthy — across Issues, PRs, and Maintainer Controls.' This slide sets the agenda for the rest of the talk.</a:t>
+              <a:t>Two directions at once, both from real public issues on GitHub. More Agentic: support AGENTS.md (5,153 reactions), OAuth HTTP MCP servers in GitHub's own copilot-cli (110), attach local images to comments, issues and pull requests (188). More Control: tldraw auto-closing external pull requests (194), rsync removing all LLM-generated commits (159), nixpkgs closing pull requests without AI disclosure (76). The tldraw issue says the policy is temporary, until GitHub provides better tools for managing contributions. That is the cue for the rest of the talk.</a:t>
+            </a:r>
+          </a:p>
+        </p:txBody>
+      </p:sp>
+      <p:sp>
+        <p:nvSpPr>
+          <p:cNvPr id="4" name="Slide Number Placeholder 3"/>
+          <p:cNvSpPr>
+            <a:spLocks noGrp="1"/>
+          </p:cNvSpPr>
+          <p:nvPr>
+            <p:ph type="sldNum" idx="5" sz="quarter"/>
+          </p:nvPr>
+        </p:nvSpPr>
+        <p:spPr/>
+      </p:sp>
+    </p:spTree>
+  </p:cSld>
+  <p:clrMapOvr>
+    <a:masterClrMapping/>
+  </p:clrMapOvr>
+</p:notes>
+</file>
+
+<file path=ppt/notesSlides/notesSlide8.xml><?xml version="1.0" encoding="utf-8"?>
+<p:notes xmlns:a="http://schemas.openxmlformats.org/drawingml/2006/main" xmlns:p="http://schemas.openxmlformats.org/presentationml/2006/main" xmlns:r="http://schemas.openxmlformats.org/officeDocument/2006/relationships">
+  <p:cSld>
+    <p:spTree>
+      <p:nvGrpSpPr>
+        <p:cNvPr id="1" name=""/>
+        <p:cNvGrpSpPr/>
+        <p:nvPr/>
+      </p:nvGrpSpPr>
+      <p:grpSpPr>
+        <a:xfrm>
+          <a:off x="0" y="0"/>
+          <a:ext cx="0" cy="0"/>
+          <a:chOff x="0" y="0"/>
+          <a:chExt cx="0" cy="0"/>
+        </a:xfrm>
+      </p:grpSpPr>
+      <p:sp>
+        <p:nvSpPr>
+          <p:cNvPr id="2" name="Slide Image Placeholder 1"/>
+          <p:cNvSpPr>
+            <a:spLocks noGrp="1"/>
+          </p:cNvSpPr>
+          <p:nvPr>
+            <p:ph type="sldImg" idx="2"/>
+          </p:nvPr>
+        </p:nvSpPr>
+        <p:spPr/>
+      </p:sp>
+      <p:sp>
+        <p:nvSpPr>
+          <p:cNvPr id="3" name="Notes Placeholder 2"/>
+          <p:cNvSpPr>
+            <a:spLocks noGrp="1"/>
+          </p:cNvSpPr>
+          <p:nvPr>
+            <p:ph type="body" idx="3" sz="quarter"/>
+          </p:nvPr>
+        </p:nvSpPr>
+        <p:spPr/>
+        <p:txBody>
+          <a:bodyPr/>
+          <a:lstStyle/>
+          <a:p>
+            <a:r>
+              <a:t>Agenda. Three places the modern GitHub experience is changing: Issues, where work gets defined. Pull Requests, where work gets reviewed. Maintainer Controls, where the rules get set.</a:t>
+            </a:r>
+          </a:p>
+        </p:txBody>
+      </p:sp>
+      <p:sp>
+        <p:nvSpPr>
+          <p:cNvPr id="4" name="Slide Number Placeholder 3"/>
+          <p:cNvSpPr>
+            <a:spLocks noGrp="1"/>
+          </p:cNvSpPr>
+          <p:nvPr>
+            <p:ph type="sldNum" idx="5" sz="quarter"/>
+          </p:nvPr>
+        </p:nvSpPr>
+        <p:spPr/>
+      </p:sp>
+    </p:spTree>
+  </p:cSld>
+  <p:clrMapOvr>
+    <a:masterClrMapping/>
+  </p:clrMapOvr>
+</p:notes>
+</file>
+
+<file path=ppt/notesSlides/notesSlide9.xml><?xml version="1.0" encoding="utf-8"?>
+<p:notes xmlns:a="http://schemas.openxmlformats.org/drawingml/2006/main" xmlns:p="http://schemas.openxmlformats.org/presentationml/2006/main" xmlns:r="http://schemas.openxmlformats.org/officeDocument/2006/relationships">
+  <p:cSld>
+    <p:spTree>
+      <p:nvGrpSpPr>
+        <p:cNvPr id="1" name=""/>
+        <p:cNvGrpSpPr/>
+        <p:nvPr/>
+      </p:nvGrpSpPr>
+      <p:grpSpPr>
+        <a:xfrm>
+          <a:off x="0" y="0"/>
+          <a:ext cx="0" cy="0"/>
+          <a:chOff x="0" y="0"/>
+          <a:chExt cx="0" cy="0"/>
+        </a:xfrm>
+      </p:grpSpPr>
+      <p:sp>
+        <p:nvSpPr>
+          <p:cNvPr id="2" name="Slide Image Placeholder 1"/>
+          <p:cNvSpPr>
+            <a:spLocks noGrp="1"/>
+          </p:cNvSpPr>
+          <p:nvPr>
+            <p:ph type="sldImg" idx="2"/>
+          </p:nvPr>
+        </p:nvSpPr>
+        <p:spPr/>
+      </p:sp>
+      <p:sp>
+        <p:nvSpPr>
+          <p:cNvPr id="3" name="Notes Placeholder 2"/>
+          <p:cNvSpPr>
+            <a:spLocks noGrp="1"/>
+          </p:cNvSpPr>
+          <p:nvPr>
+            <p:ph type="body" idx="3" sz="quarter"/>
+          </p:nvPr>
+        </p:nvSpPr>
+        <p:spPr/>
+        <p:txBody>
+          <a:bodyPr/>
+          <a:lstStyle/>
+          <a:p>
+            <a:r>
+              <a:t>Demo one, Issues. gh issue comment 1 --attach broken-title-slide.png. The CLI uploads the image and rewrites the reference in the comment body, so an agent can file visual evidence without a browser. This shipped from cli/cli#13256.</a:t>
             </a:r>
           </a:p>
         </p:txBody>
@@ -4212,7 +4504,259 @@
       <p:grpSpPr/>
       <p:pic>
         <p:nvPicPr>
-          <p:cNvPr id="2" name="A New Way To Build Software: How GitHub Is Evolving For a Human, Agent Future. AGNTCon Europe 2026. Marlene Mhangami." descr="A New Way To Build Software: How GitHub Is Evolving For a Human, Agent Future. AGNTCon Europe 2026. Marlene Mhangami."/>
+          <p:cNvPr id="2" name="Picture 1" descr="slide-01-title.png"/>
+          <p:cNvPicPr>
+            <a:picLocks noChangeAspect="1"/>
+          </p:cNvPicPr>
+          <p:nvPr/>
+        </p:nvPicPr>
+        <p:blipFill>
+          <a:blip r:embed="rId2"/>
+          <a:stretch>
+            <a:fillRect/>
+          </a:stretch>
+        </p:blipFill>
+        <p:spPr>
+          <a:xfrm>
+            <a:off x="0" y="0"/>
+            <a:ext cx="12192000" cy="6858000"/>
+          </a:xfrm>
+          <a:prstGeom prst="rect">
+            <a:avLst/>
+          </a:prstGeom>
+        </p:spPr>
+      </p:pic>
+    </p:spTree>
+  </p:cSld>
+  <p:clrMapOvr>
+    <a:masterClrMapping/>
+  </p:clrMapOvr>
+</p:sld>
+</file>
+
+<file path=ppt/slides/slide10.xml><?xml version="1.0" encoding="utf-8"?>
+<p:sld xmlns:a="http://schemas.openxmlformats.org/drawingml/2006/main" xmlns:p="http://schemas.openxmlformats.org/presentationml/2006/main" xmlns:r="http://schemas.openxmlformats.org/officeDocument/2006/relationships">
+  <p:cSld>
+    <p:spTree>
+      <p:nvGrpSpPr>
+        <p:cNvPr id="1" name=""/>
+        <p:cNvGrpSpPr/>
+        <p:nvPr/>
+      </p:nvGrpSpPr>
+      <p:grpSpPr/>
+      <p:pic>
+        <p:nvPicPr>
+          <p:cNvPr id="2" name="Picture 1" descr="slide-10-demo-issue-artifacts.png"/>
+          <p:cNvPicPr>
+            <a:picLocks noChangeAspect="1"/>
+          </p:cNvPicPr>
+          <p:nvPr/>
+        </p:nvPicPr>
+        <p:blipFill>
+          <a:blip r:embed="rId2"/>
+          <a:stretch>
+            <a:fillRect/>
+          </a:stretch>
+        </p:blipFill>
+        <p:spPr>
+          <a:xfrm>
+            <a:off x="0" y="0"/>
+            <a:ext cx="12192000" cy="6858000"/>
+          </a:xfrm>
+          <a:prstGeom prst="rect">
+            <a:avLst/>
+          </a:prstGeom>
+        </p:spPr>
+      </p:pic>
+    </p:spTree>
+  </p:cSld>
+  <p:clrMapOvr>
+    <a:masterClrMapping/>
+  </p:clrMapOvr>
+</p:sld>
+</file>
+
+<file path=ppt/slides/slide11.xml><?xml version="1.0" encoding="utf-8"?>
+<p:sld xmlns:a="http://schemas.openxmlformats.org/drawingml/2006/main" xmlns:p="http://schemas.openxmlformats.org/presentationml/2006/main" xmlns:r="http://schemas.openxmlformats.org/officeDocument/2006/relationships">
+  <p:cSld>
+    <p:spTree>
+      <p:nvGrpSpPr>
+        <p:cNvPr id="1" name=""/>
+        <p:cNvGrpSpPr/>
+        <p:nvPr/>
+      </p:nvGrpSpPr>
+      <p:grpSpPr/>
+      <p:pic>
+        <p:nvPicPr>
+          <p:cNvPr id="2" name="Picture 1" descr="slide-11-demo-stacked-prs.png"/>
+          <p:cNvPicPr>
+            <a:picLocks noChangeAspect="1"/>
+          </p:cNvPicPr>
+          <p:nvPr/>
+        </p:nvPicPr>
+        <p:blipFill>
+          <a:blip r:embed="rId2"/>
+          <a:stretch>
+            <a:fillRect/>
+          </a:stretch>
+        </p:blipFill>
+        <p:spPr>
+          <a:xfrm>
+            <a:off x="0" y="0"/>
+            <a:ext cx="12192000" cy="6858000"/>
+          </a:xfrm>
+          <a:prstGeom prst="rect">
+            <a:avLst/>
+          </a:prstGeom>
+        </p:spPr>
+      </p:pic>
+    </p:spTree>
+  </p:cSld>
+  <p:clrMapOvr>
+    <a:masterClrMapping/>
+  </p:clrMapOvr>
+</p:sld>
+</file>
+
+<file path=ppt/slides/slide12.xml><?xml version="1.0" encoding="utf-8"?>
+<p:sld xmlns:a="http://schemas.openxmlformats.org/drawingml/2006/main" xmlns:p="http://schemas.openxmlformats.org/presentationml/2006/main" xmlns:r="http://schemas.openxmlformats.org/officeDocument/2006/relationships">
+  <p:cSld>
+    <p:spTree>
+      <p:nvGrpSpPr>
+        <p:cNvPr id="1" name=""/>
+        <p:cNvGrpSpPr/>
+        <p:nvPr/>
+      </p:nvGrpSpPr>
+      <p:grpSpPr/>
+      <p:pic>
+        <p:nvPicPr>
+          <p:cNvPr id="2" name="Picture 1" descr="slide-12-demo-pr-experience.png"/>
+          <p:cNvPicPr>
+            <a:picLocks noChangeAspect="1"/>
+          </p:cNvPicPr>
+          <p:nvPr/>
+        </p:nvPicPr>
+        <p:blipFill>
+          <a:blip r:embed="rId2"/>
+          <a:stretch>
+            <a:fillRect/>
+          </a:stretch>
+        </p:blipFill>
+        <p:spPr>
+          <a:xfrm>
+            <a:off x="0" y="0"/>
+            <a:ext cx="12192000" cy="6858000"/>
+          </a:xfrm>
+          <a:prstGeom prst="rect">
+            <a:avLst/>
+          </a:prstGeom>
+        </p:spPr>
+      </p:pic>
+    </p:spTree>
+  </p:cSld>
+  <p:clrMapOvr>
+    <a:masterClrMapping/>
+  </p:clrMapOvr>
+</p:sld>
+</file>
+
+<file path=ppt/slides/slide13.xml><?xml version="1.0" encoding="utf-8"?>
+<p:sld xmlns:a="http://schemas.openxmlformats.org/drawingml/2006/main" xmlns:p="http://schemas.openxmlformats.org/presentationml/2006/main" xmlns:r="http://schemas.openxmlformats.org/officeDocument/2006/relationships">
+  <p:cSld>
+    <p:spTree>
+      <p:nvGrpSpPr>
+        <p:cNvPr id="1" name=""/>
+        <p:cNvGrpSpPr/>
+        <p:nvPr/>
+      </p:nvGrpSpPr>
+      <p:grpSpPr/>
+      <p:pic>
+        <p:nvPicPr>
+          <p:cNvPr id="2" name="Picture 1" descr="slide-13-maintainer-controls.png"/>
+          <p:cNvPicPr>
+            <a:picLocks noChangeAspect="1"/>
+          </p:cNvPicPr>
+          <p:nvPr/>
+        </p:nvPicPr>
+        <p:blipFill>
+          <a:blip r:embed="rId2"/>
+          <a:stretch>
+            <a:fillRect/>
+          </a:stretch>
+        </p:blipFill>
+        <p:spPr>
+          <a:xfrm>
+            <a:off x="0" y="0"/>
+            <a:ext cx="12192000" cy="6858000"/>
+          </a:xfrm>
+          <a:prstGeom prst="rect">
+            <a:avLst/>
+          </a:prstGeom>
+        </p:spPr>
+      </p:pic>
+    </p:spTree>
+  </p:cSld>
+  <p:clrMapOvr>
+    <a:masterClrMapping/>
+  </p:clrMapOvr>
+</p:sld>
+</file>
+
+<file path=ppt/slides/slide14.xml><?xml version="1.0" encoding="utf-8"?>
+<p:sld xmlns:a="http://schemas.openxmlformats.org/drawingml/2006/main" xmlns:p="http://schemas.openxmlformats.org/presentationml/2006/main" xmlns:r="http://schemas.openxmlformats.org/officeDocument/2006/relationships">
+  <p:cSld>
+    <p:spTree>
+      <p:nvGrpSpPr>
+        <p:cNvPr id="1" name=""/>
+        <p:cNvGrpSpPr/>
+        <p:nvPr/>
+      </p:nvGrpSpPr>
+      <p:grpSpPr/>
+      <p:pic>
+        <p:nvPicPr>
+          <p:cNvPr id="2" name="Picture 1" descr="slide-14-agentic-surfaces.png"/>
+          <p:cNvPicPr>
+            <a:picLocks noChangeAspect="1"/>
+          </p:cNvPicPr>
+          <p:nvPr/>
+        </p:nvPicPr>
+        <p:blipFill>
+          <a:blip r:embed="rId2"/>
+          <a:stretch>
+            <a:fillRect/>
+          </a:stretch>
+        </p:blipFill>
+        <p:spPr>
+          <a:xfrm>
+            <a:off x="0" y="0"/>
+            <a:ext cx="12192000" cy="6858000"/>
+          </a:xfrm>
+          <a:prstGeom prst="rect">
+            <a:avLst/>
+          </a:prstGeom>
+        </p:spPr>
+      </p:pic>
+    </p:spTree>
+  </p:cSld>
+  <p:clrMapOvr>
+    <a:masterClrMapping/>
+  </p:clrMapOvr>
+</p:sld>
+</file>
+
+<file path=ppt/slides/slide15.xml><?xml version="1.0" encoding="utf-8"?>
+<p:sld xmlns:a="http://schemas.openxmlformats.org/drawingml/2006/main" xmlns:p="http://schemas.openxmlformats.org/presentationml/2006/main" xmlns:r="http://schemas.openxmlformats.org/officeDocument/2006/relationships">
+  <p:cSld>
+    <p:spTree>
+      <p:nvGrpSpPr>
+        <p:cNvPr id="1" name=""/>
+        <p:cNvGrpSpPr/>
+        <p:nvPr/>
+      </p:nvGrpSpPr>
+      <p:grpSpPr/>
+      <p:pic>
+        <p:nvPicPr>
+          <p:cNvPr id="2" name="Picture 1" descr="slide-15-thank-you.png"/>
           <p:cNvPicPr>
             <a:picLocks noChangeAspect="1"/>
           </p:cNvPicPr>
@@ -4254,7 +4798,7 @@
       <p:grpSpPr/>
       <p:pic>
         <p:nvPicPr>
-          <p:cNvPr id="2" name="GitHub's complete published chart from 2023 to August 2026: 130M merged pull requests per month, 2.9B commits per month, and 24M new repositories per month. Light-theme treatment, preserving the publi" descr="GitHub's complete published chart from 2023 to August 2026: 130M merged pull requests per month, 2.9B commits per month, and 24M new repositories per month. Light-theme treatment, preserving the published curves and axes. Caption: GitHub reached 1.15B commits per week in August 2026. Weekly caption and monthly plots are distinct."/>
+          <p:cNvPr id="2" name="Picture 1" descr="slide-02-more-code.png"/>
           <p:cNvPicPr>
             <a:picLocks noChangeAspect="1"/>
           </p:cNvPicPr>
@@ -4296,7 +4840,7 @@
       <p:grpSpPr/>
       <p:pic>
         <p:nvPicPr>
-          <p:cNvPr id="2" name="Agent Driven Growth. Two illustrative mini-charts. Left: agent-created pull requests reached 17.8 million in March 2026, up roughly four times in six months, shown as ascending bars. Right: monthly co" descr="Agent Driven Growth. Two illustrative mini-charts. Left: agent-created pull requests reached 17.8 million in March 2026, up roughly four times in six months, shown as ascending bars. Right: monthly commits on GitHub rose from 1.4 billion in April 2026 to 2.9 billion in August 2026, roughly doubling, shown as a rising line. For context, GitHub recorded about 1 billion commits in all of 2024."/>
+          <p:cNvPr id="2" name="Picture 1" descr="slide-03-scale-of-the-shift.png"/>
           <p:cNvPicPr>
             <a:picLocks noChangeAspect="1"/>
           </p:cNvPicPr>
@@ -4338,7 +4882,7 @@
       <p:grpSpPr/>
       <p:pic>
         <p:nvPicPr>
-          <p:cNvPr id="2" name="Statement slide: AI has boosted productivity for some, and left others feeling overwhelmed." descr="Statement slide: AI has boosted productivity for some, and left others feeling overwhelmed."/>
+          <p:cNvPr id="2" name="Picture 1" descr="slide-04-automation-compounding.png"/>
           <p:cNvPicPr>
             <a:picLocks noChangeAspect="1"/>
           </p:cNvPicPr>
@@ -4380,7 +4924,7 @@
       <p:grpSpPr/>
       <p:pic>
         <p:nvPicPr>
-          <p:cNvPr id="2" name="issues background" descr="Two zones of real public GitHub issues. Left, 'Leaning In' — developers asking for more agent power: cli/cli #11845 (gh agent-task create should not require OAUTH tokens, 44 reactions); cli/cli #12960 (image/file attachments in gh issue create, critical for agentic workflows, shown with 63 reactions); github/spec-kit #269 (support multiple coding agents, 21 reactions). Right, 'Overwhelmed' — maintainers asking for guardrails: rust-lang/this-week-in-rust #6861 (suspicious AI-generated article, possible supply-chain attack, 60 reactions); mastodon/mastodon #38072 (consider not allowing LLM and AI contributions, 40 reactions); rust-lang/leadership-council #273 (policy proposal: no low-effort contributions, 38 reactions). Each card drops onto its side of the screen."/>
+          <p:cNvPr id="2" name="Picture 1" descr="slide-05-whats-changed.png"/>
           <p:cNvPicPr>
             <a:picLocks noChangeAspect="1"/>
           </p:cNvPicPr>
@@ -4402,533 +4946,11 @@
           </a:prstGeom>
         </p:spPr>
       </p:pic>
-      <p:pic>
-        <p:nvPicPr>
-          <p:cNvPr id="3" name="issue slide-06-card-1.png" descr="slide-06-card-1.png"/>
-          <p:cNvPicPr>
-            <a:picLocks noChangeAspect="1"/>
-          </p:cNvPicPr>
-          <p:nvPr/>
-        </p:nvPicPr>
-        <p:blipFill>
-          <a:blip r:embed="rId3"/>
-          <a:stretch>
-            <a:fillRect/>
-          </a:stretch>
-        </p:blipFill>
-        <p:spPr>
-          <a:xfrm>
-            <a:off x="571500" y="1381125"/>
-            <a:ext cx="5191125" cy="1504950"/>
-          </a:xfrm>
-          <a:prstGeom prst="rect">
-            <a:avLst/>
-          </a:prstGeom>
-        </p:spPr>
-      </p:pic>
-      <p:pic>
-        <p:nvPicPr>
-          <p:cNvPr id="4" name="issue slide-06-card-2.png" descr="slide-06-card-2.png"/>
-          <p:cNvPicPr>
-            <a:picLocks noChangeAspect="1"/>
-          </p:cNvPicPr>
-          <p:nvPr/>
-        </p:nvPicPr>
-        <p:blipFill>
-          <a:blip r:embed="rId4"/>
-          <a:stretch>
-            <a:fillRect/>
-          </a:stretch>
-        </p:blipFill>
-        <p:spPr>
-          <a:xfrm>
-            <a:off x="571500" y="2762250"/>
-            <a:ext cx="5191125" cy="1504950"/>
-          </a:xfrm>
-          <a:prstGeom prst="rect">
-            <a:avLst/>
-          </a:prstGeom>
-        </p:spPr>
-      </p:pic>
-      <p:pic>
-        <p:nvPicPr>
-          <p:cNvPr id="5" name="issue slide-06-card-3.png" descr="slide-06-card-3.png"/>
-          <p:cNvPicPr>
-            <a:picLocks noChangeAspect="1"/>
-          </p:cNvPicPr>
-          <p:nvPr/>
-        </p:nvPicPr>
-        <p:blipFill>
-          <a:blip r:embed="rId5"/>
-          <a:stretch>
-            <a:fillRect/>
-          </a:stretch>
-        </p:blipFill>
-        <p:spPr>
-          <a:xfrm>
-            <a:off x="571500" y="4143375"/>
-            <a:ext cx="5191125" cy="1504950"/>
-          </a:xfrm>
-          <a:prstGeom prst="rect">
-            <a:avLst/>
-          </a:prstGeom>
-        </p:spPr>
-      </p:pic>
-      <p:pic>
-        <p:nvPicPr>
-          <p:cNvPr id="6" name="issue slide-06-card-4.png" descr="slide-06-card-4.png"/>
-          <p:cNvPicPr>
-            <a:picLocks noChangeAspect="1"/>
-          </p:cNvPicPr>
-          <p:nvPr/>
-        </p:nvPicPr>
-        <p:blipFill>
-          <a:blip r:embed="rId6"/>
-          <a:stretch>
-            <a:fillRect/>
-          </a:stretch>
-        </p:blipFill>
-        <p:spPr>
-          <a:xfrm>
-            <a:off x="6429375" y="1381125"/>
-            <a:ext cx="5191125" cy="1504950"/>
-          </a:xfrm>
-          <a:prstGeom prst="rect">
-            <a:avLst/>
-          </a:prstGeom>
-        </p:spPr>
-      </p:pic>
-      <p:pic>
-        <p:nvPicPr>
-          <p:cNvPr id="7" name="issue slide-06-card-5.png" descr="slide-06-card-5.png"/>
-          <p:cNvPicPr>
-            <a:picLocks noChangeAspect="1"/>
-          </p:cNvPicPr>
-          <p:nvPr/>
-        </p:nvPicPr>
-        <p:blipFill>
-          <a:blip r:embed="rId7"/>
-          <a:stretch>
-            <a:fillRect/>
-          </a:stretch>
-        </p:blipFill>
-        <p:spPr>
-          <a:xfrm>
-            <a:off x="6429375" y="2762250"/>
-            <a:ext cx="5191125" cy="1504950"/>
-          </a:xfrm>
-          <a:prstGeom prst="rect">
-            <a:avLst/>
-          </a:prstGeom>
-        </p:spPr>
-      </p:pic>
-      <p:pic>
-        <p:nvPicPr>
-          <p:cNvPr id="8" name="issue slide-06-card-6.png" descr="slide-06-card-6.png"/>
-          <p:cNvPicPr>
-            <a:picLocks noChangeAspect="1"/>
-          </p:cNvPicPr>
-          <p:nvPr/>
-        </p:nvPicPr>
-        <p:blipFill>
-          <a:blip r:embed="rId8"/>
-          <a:stretch>
-            <a:fillRect/>
-          </a:stretch>
-        </p:blipFill>
-        <p:spPr>
-          <a:xfrm>
-            <a:off x="6429375" y="4143375"/>
-            <a:ext cx="5191125" cy="1504950"/>
-          </a:xfrm>
-          <a:prstGeom prst="rect">
-            <a:avLst/>
-          </a:prstGeom>
-        </p:spPr>
-      </p:pic>
     </p:spTree>
   </p:cSld>
   <p:clrMapOvr>
     <a:masterClrMapping/>
   </p:clrMapOvr>
-  <p:timing>
-    <p:tnLst>
-      <p:par>
-        <p:cTn id="1" dur="indefinite" restart="never" nodeType="tmRoot">
-          <p:childTnLst>
-            <p:seq concurrent="1" nextAc="seek">
-              <p:cTn id="2" dur="indefinite" nodeType="mainSeq">
-                <p:childTnLst>
-                  <p:par>
-                    <p:cTn id="3" fill="hold">
-                      <p:stCondLst>
-                        <p:cond delay="indefinite"/>
-                      </p:stCondLst>
-                      <p:childTnLst>
-                        <p:par>
-                          <p:cTn id="4" fill="hold">
-                            <p:stCondLst>
-                              <p:cond delay="0"/>
-                            </p:stCondLst>
-                            <p:childTnLst>
-                              <p:par>
-                                <p:cTn id="10" presetID="2" presetClass="entr" presetSubtype="4" fill="hold" grpId="0" nodeType="afterEffect">
-                                  <p:stCondLst>
-                                    <p:cond delay="500"/>
-                                  </p:stCondLst>
-                                  <p:childTnLst>
-                                    <p:set>
-                                      <p:cBhvr>
-                                        <p:cTn id="11" dur="1" fill="hold">
-                                          <p:stCondLst>
-                                            <p:cond delay="0"/>
-                                          </p:stCondLst>
-                                        </p:cTn>
-                                        <p:tgtEl>
-                                          <p:spTgt spid="3"/>
-                                        </p:tgtEl>
-                                        <p:attrNameLst>
-                                          <p:attrName>style.visibility</p:attrName>
-                                        </p:attrNameLst>
-                                      </p:cBhvr>
-                                      <p:to>
-                                        <p:strVal val="visible"/>
-                                      </p:to>
-                                    </p:set>
-                                    <p:anim calcmode="lin" valueType="num">
-                                      <p:cBhvr additive="base">
-                                        <p:cTn id="12" dur="600" fill="hold"/>
-                                        <p:tgtEl>
-                                          <p:spTgt spid="3"/>
-                                        </p:tgtEl>
-                                        <p:attrNameLst>
-                                          <p:attrName>ppt_y</p:attrName>
-                                        </p:attrNameLst>
-                                      </p:cBhvr>
-                                      <p:tavLst>
-                                        <p:tav tm="0">
-                                          <p:val>
-                                            <p:strVal val="#ppt_y-1"/>
-                                          </p:val>
-                                        </p:tav>
-                                        <p:tav tm="74000">
-                                          <p:val>
-                                            <p:strVal val="#ppt_y+0.018"/>
-                                          </p:val>
-                                        </p:tav>
-                                        <p:tav tm="100000">
-                                          <p:val>
-                                            <p:strVal val="#ppt_y"/>
-                                          </p:val>
-                                        </p:tav>
-                                      </p:tavLst>
-                                    </p:anim>
-                                  </p:childTnLst>
-                                </p:cTn>
-                              </p:par>
-                              <p:par>
-                                <p:cTn id="13" presetID="2" presetClass="entr" presetSubtype="4" fill="hold" grpId="0" nodeType="withEffect">
-                                  <p:stCondLst>
-                                    <p:cond delay="760"/>
-                                  </p:stCondLst>
-                                  <p:childTnLst>
-                                    <p:set>
-                                      <p:cBhvr>
-                                        <p:cTn id="14" dur="1" fill="hold">
-                                          <p:stCondLst>
-                                            <p:cond delay="0"/>
-                                          </p:stCondLst>
-                                        </p:cTn>
-                                        <p:tgtEl>
-                                          <p:spTgt spid="6"/>
-                                        </p:tgtEl>
-                                        <p:attrNameLst>
-                                          <p:attrName>style.visibility</p:attrName>
-                                        </p:attrNameLst>
-                                      </p:cBhvr>
-                                      <p:to>
-                                        <p:strVal val="visible"/>
-                                      </p:to>
-                                    </p:set>
-                                    <p:anim calcmode="lin" valueType="num">
-                                      <p:cBhvr additive="base">
-                                        <p:cTn id="15" dur="600" fill="hold"/>
-                                        <p:tgtEl>
-                                          <p:spTgt spid="6"/>
-                                        </p:tgtEl>
-                                        <p:attrNameLst>
-                                          <p:attrName>ppt_y</p:attrName>
-                                        </p:attrNameLst>
-                                      </p:cBhvr>
-                                      <p:tavLst>
-                                        <p:tav tm="0">
-                                          <p:val>
-                                            <p:strVal val="#ppt_y-1"/>
-                                          </p:val>
-                                        </p:tav>
-                                        <p:tav tm="74000">
-                                          <p:val>
-                                            <p:strVal val="#ppt_y+0.018"/>
-                                          </p:val>
-                                        </p:tav>
-                                        <p:tav tm="100000">
-                                          <p:val>
-                                            <p:strVal val="#ppt_y"/>
-                                          </p:val>
-                                        </p:tav>
-                                      </p:tavLst>
-                                    </p:anim>
-                                  </p:childTnLst>
-                                </p:cTn>
-                              </p:par>
-                              <p:par>
-                                <p:cTn id="16" presetID="2" presetClass="entr" presetSubtype="4" fill="hold" grpId="0" nodeType="withEffect">
-                                  <p:stCondLst>
-                                    <p:cond delay="1020"/>
-                                  </p:stCondLst>
-                                  <p:childTnLst>
-                                    <p:set>
-                                      <p:cBhvr>
-                                        <p:cTn id="17" dur="1" fill="hold">
-                                          <p:stCondLst>
-                                            <p:cond delay="0"/>
-                                          </p:stCondLst>
-                                        </p:cTn>
-                                        <p:tgtEl>
-                                          <p:spTgt spid="4"/>
-                                        </p:tgtEl>
-                                        <p:attrNameLst>
-                                          <p:attrName>style.visibility</p:attrName>
-                                        </p:attrNameLst>
-                                      </p:cBhvr>
-                                      <p:to>
-                                        <p:strVal val="visible"/>
-                                      </p:to>
-                                    </p:set>
-                                    <p:anim calcmode="lin" valueType="num">
-                                      <p:cBhvr additive="base">
-                                        <p:cTn id="18" dur="600" fill="hold"/>
-                                        <p:tgtEl>
-                                          <p:spTgt spid="4"/>
-                                        </p:tgtEl>
-                                        <p:attrNameLst>
-                                          <p:attrName>ppt_y</p:attrName>
-                                        </p:attrNameLst>
-                                      </p:cBhvr>
-                                      <p:tavLst>
-                                        <p:tav tm="0">
-                                          <p:val>
-                                            <p:strVal val="#ppt_y-1"/>
-                                          </p:val>
-                                        </p:tav>
-                                        <p:tav tm="74000">
-                                          <p:val>
-                                            <p:strVal val="#ppt_y+0.018"/>
-                                          </p:val>
-                                        </p:tav>
-                                        <p:tav tm="100000">
-                                          <p:val>
-                                            <p:strVal val="#ppt_y"/>
-                                          </p:val>
-                                        </p:tav>
-                                      </p:tavLst>
-                                    </p:anim>
-                                  </p:childTnLst>
-                                </p:cTn>
-                              </p:par>
-                              <p:par>
-                                <p:cTn id="19" presetID="2" presetClass="entr" presetSubtype="4" fill="hold" grpId="0" nodeType="withEffect">
-                                  <p:stCondLst>
-                                    <p:cond delay="1280"/>
-                                  </p:stCondLst>
-                                  <p:childTnLst>
-                                    <p:set>
-                                      <p:cBhvr>
-                                        <p:cTn id="20" dur="1" fill="hold">
-                                          <p:stCondLst>
-                                            <p:cond delay="0"/>
-                                          </p:stCondLst>
-                                        </p:cTn>
-                                        <p:tgtEl>
-                                          <p:spTgt spid="7"/>
-                                        </p:tgtEl>
-                                        <p:attrNameLst>
-                                          <p:attrName>style.visibility</p:attrName>
-                                        </p:attrNameLst>
-                                      </p:cBhvr>
-                                      <p:to>
-                                        <p:strVal val="visible"/>
-                                      </p:to>
-                                    </p:set>
-                                    <p:anim calcmode="lin" valueType="num">
-                                      <p:cBhvr additive="base">
-                                        <p:cTn id="21" dur="600" fill="hold"/>
-                                        <p:tgtEl>
-                                          <p:spTgt spid="7"/>
-                                        </p:tgtEl>
-                                        <p:attrNameLst>
-                                          <p:attrName>ppt_y</p:attrName>
-                                        </p:attrNameLst>
-                                      </p:cBhvr>
-                                      <p:tavLst>
-                                        <p:tav tm="0">
-                                          <p:val>
-                                            <p:strVal val="#ppt_y-1"/>
-                                          </p:val>
-                                        </p:tav>
-                                        <p:tav tm="74000">
-                                          <p:val>
-                                            <p:strVal val="#ppt_y+0.018"/>
-                                          </p:val>
-                                        </p:tav>
-                                        <p:tav tm="100000">
-                                          <p:val>
-                                            <p:strVal val="#ppt_y"/>
-                                          </p:val>
-                                        </p:tav>
-                                      </p:tavLst>
-                                    </p:anim>
-                                  </p:childTnLst>
-                                </p:cTn>
-                              </p:par>
-                              <p:par>
-                                <p:cTn id="22" presetID="2" presetClass="entr" presetSubtype="4" fill="hold" grpId="0" nodeType="withEffect">
-                                  <p:stCondLst>
-                                    <p:cond delay="1540"/>
-                                  </p:stCondLst>
-                                  <p:childTnLst>
-                                    <p:set>
-                                      <p:cBhvr>
-                                        <p:cTn id="23" dur="1" fill="hold">
-                                          <p:stCondLst>
-                                            <p:cond delay="0"/>
-                                          </p:stCondLst>
-                                        </p:cTn>
-                                        <p:tgtEl>
-                                          <p:spTgt spid="5"/>
-                                        </p:tgtEl>
-                                        <p:attrNameLst>
-                                          <p:attrName>style.visibility</p:attrName>
-                                        </p:attrNameLst>
-                                      </p:cBhvr>
-                                      <p:to>
-                                        <p:strVal val="visible"/>
-                                      </p:to>
-                                    </p:set>
-                                    <p:anim calcmode="lin" valueType="num">
-                                      <p:cBhvr additive="base">
-                                        <p:cTn id="24" dur="600" fill="hold"/>
-                                        <p:tgtEl>
-                                          <p:spTgt spid="5"/>
-                                        </p:tgtEl>
-                                        <p:attrNameLst>
-                                          <p:attrName>ppt_y</p:attrName>
-                                        </p:attrNameLst>
-                                      </p:cBhvr>
-                                      <p:tavLst>
-                                        <p:tav tm="0">
-                                          <p:val>
-                                            <p:strVal val="#ppt_y-1"/>
-                                          </p:val>
-                                        </p:tav>
-                                        <p:tav tm="74000">
-                                          <p:val>
-                                            <p:strVal val="#ppt_y+0.018"/>
-                                          </p:val>
-                                        </p:tav>
-                                        <p:tav tm="100000">
-                                          <p:val>
-                                            <p:strVal val="#ppt_y"/>
-                                          </p:val>
-                                        </p:tav>
-                                      </p:tavLst>
-                                    </p:anim>
-                                  </p:childTnLst>
-                                </p:cTn>
-                              </p:par>
-                              <p:par>
-                                <p:cTn id="25" presetID="2" presetClass="entr" presetSubtype="4" fill="hold" grpId="0" nodeType="withEffect">
-                                  <p:stCondLst>
-                                    <p:cond delay="1800"/>
-                                  </p:stCondLst>
-                                  <p:childTnLst>
-                                    <p:set>
-                                      <p:cBhvr>
-                                        <p:cTn id="26" dur="1" fill="hold">
-                                          <p:stCondLst>
-                                            <p:cond delay="0"/>
-                                          </p:stCondLst>
-                                        </p:cTn>
-                                        <p:tgtEl>
-                                          <p:spTgt spid="8"/>
-                                        </p:tgtEl>
-                                        <p:attrNameLst>
-                                          <p:attrName>style.visibility</p:attrName>
-                                        </p:attrNameLst>
-                                      </p:cBhvr>
-                                      <p:to>
-                                        <p:strVal val="visible"/>
-                                      </p:to>
-                                    </p:set>
-                                    <p:anim calcmode="lin" valueType="num">
-                                      <p:cBhvr additive="base">
-                                        <p:cTn id="27" dur="600" fill="hold"/>
-                                        <p:tgtEl>
-                                          <p:spTgt spid="8"/>
-                                        </p:tgtEl>
-                                        <p:attrNameLst>
-                                          <p:attrName>ppt_y</p:attrName>
-                                        </p:attrNameLst>
-                                      </p:cBhvr>
-                                      <p:tavLst>
-                                        <p:tav tm="0">
-                                          <p:val>
-                                            <p:strVal val="#ppt_y-1"/>
-                                          </p:val>
-                                        </p:tav>
-                                        <p:tav tm="74000">
-                                          <p:val>
-                                            <p:strVal val="#ppt_y+0.018"/>
-                                          </p:val>
-                                        </p:tav>
-                                        <p:tav tm="100000">
-                                          <p:val>
-                                            <p:strVal val="#ppt_y"/>
-                                          </p:val>
-                                        </p:tav>
-                                      </p:tavLst>
-                                    </p:anim>
-                                  </p:childTnLst>
-                                </p:cTn>
-                              </p:par>
-                            </p:childTnLst>
-                          </p:cTn>
-                        </p:par>
-                      </p:childTnLst>
-                    </p:cTn>
-                  </p:par>
-                </p:childTnLst>
-              </p:cTn>
-              <p:prevCondLst>
-                <p:cond evt="onPrev" delay="0">
-                  <p:tgtEl>
-                    <p:sldTgt/>
-                  </p:tgtEl>
-                </p:cond>
-              </p:prevCondLst>
-              <p:nextCondLst>
-                <p:cond evt="onNext" delay="0">
-                  <p:tgtEl>
-                    <p:sldTgt/>
-                  </p:tgtEl>
-                </p:cond>
-              </p:nextCondLst>
-            </p:seq>
-          </p:childTnLst>
-        </p:cTn>
-      </p:par>
-    </p:tnLst>
-  </p:timing>
 </p:sld>
 </file>
 
@@ -4944,7 +4966,7 @@
       <p:grpSpPr/>
       <p:pic>
         <p:nvPicPr>
-          <p:cNvPr id="2" name="Section-divider slide: The Modern GitHub Experience." descr="Section-divider slide: The Modern GitHub Experience."/>
+          <p:cNvPr id="2" name="Picture 1" descr="slide-06-transition-developers.png"/>
           <p:cNvPicPr>
             <a:picLocks noChangeAspect="1"/>
           </p:cNvPicPr>
@@ -4986,7 +5008,91 @@
       <p:grpSpPr/>
       <p:pic>
         <p:nvPicPr>
-          <p:cNvPr id="2" name="The Modern GitHub Experience. Three bullets: Issues; PRs; Maintainer Controls." descr="The Modern GitHub Experience. Three bullets: Issues; PRs; Maintainer Controls."/>
+          <p:cNvPr id="2" name="Picture 1" descr="slide-07-developers-and-ai.png"/>
+          <p:cNvPicPr>
+            <a:picLocks noChangeAspect="1"/>
+          </p:cNvPicPr>
+          <p:nvPr/>
+        </p:nvPicPr>
+        <p:blipFill>
+          <a:blip r:embed="rId2"/>
+          <a:stretch>
+            <a:fillRect/>
+          </a:stretch>
+        </p:blipFill>
+        <p:spPr>
+          <a:xfrm>
+            <a:off x="0" y="0"/>
+            <a:ext cx="12192000" cy="6858000"/>
+          </a:xfrm>
+          <a:prstGeom prst="rect">
+            <a:avLst/>
+          </a:prstGeom>
+        </p:spPr>
+      </p:pic>
+    </p:spTree>
+  </p:cSld>
+  <p:clrMapOvr>
+    <a:masterClrMapping/>
+  </p:clrMapOvr>
+</p:sld>
+</file>
+
+<file path=ppt/slides/slide8.xml><?xml version="1.0" encoding="utf-8"?>
+<p:sld xmlns:a="http://schemas.openxmlformats.org/drawingml/2006/main" xmlns:p="http://schemas.openxmlformats.org/presentationml/2006/main" xmlns:r="http://schemas.openxmlformats.org/officeDocument/2006/relationships">
+  <p:cSld>
+    <p:spTree>
+      <p:nvGrpSpPr>
+        <p:cNvPr id="1" name=""/>
+        <p:cNvGrpSpPr/>
+        <p:nvPr/>
+      </p:nvGrpSpPr>
+      <p:grpSpPr/>
+      <p:pic>
+        <p:nvPicPr>
+          <p:cNvPr id="2" name="Picture 1" descr="slide-08-modern-github-experience.png"/>
+          <p:cNvPicPr>
+            <a:picLocks noChangeAspect="1"/>
+          </p:cNvPicPr>
+          <p:nvPr/>
+        </p:nvPicPr>
+        <p:blipFill>
+          <a:blip r:embed="rId2"/>
+          <a:stretch>
+            <a:fillRect/>
+          </a:stretch>
+        </p:blipFill>
+        <p:spPr>
+          <a:xfrm>
+            <a:off x="0" y="0"/>
+            <a:ext cx="12192000" cy="6858000"/>
+          </a:xfrm>
+          <a:prstGeom prst="rect">
+            <a:avLst/>
+          </a:prstGeom>
+        </p:spPr>
+      </p:pic>
+    </p:spTree>
+  </p:cSld>
+  <p:clrMapOvr>
+    <a:masterClrMapping/>
+  </p:clrMapOvr>
+</p:sld>
+</file>
+
+<file path=ppt/slides/slide9.xml><?xml version="1.0" encoding="utf-8"?>
+<p:sld xmlns:a="http://schemas.openxmlformats.org/drawingml/2006/main" xmlns:p="http://schemas.openxmlformats.org/presentationml/2006/main" xmlns:r="http://schemas.openxmlformats.org/officeDocument/2006/relationships">
+  <p:cSld>
+    <p:spTree>
+      <p:nvGrpSpPr>
+        <p:cNvPr id="1" name=""/>
+        <p:cNvGrpSpPr/>
+        <p:nvPr/>
+      </p:nvGrpSpPr>
+      <p:grpSpPr/>
+      <p:pic>
+        <p:nvPicPr>
+          <p:cNvPr id="2" name="Picture 1" descr="slide-09-demo-attach.png"/>
           <p:cNvPicPr>
             <a:picLocks noChangeAspect="1"/>
           </p:cNvPicPr>

</xml_diff>